<commit_message>
Extended the presentation with new slides
</commit_message>
<xml_diff>
--- a/documentation/SWOT.pptx
+++ b/documentation/SWOT.pptx
@@ -268,7 +268,7 @@
           <a:p>
             <a:fld id="{5C562405-84C2-4048-9C4C-220ACFA9AFD9}" type="datetimeFigureOut">
               <a:rPr lang="en-US" smtClean="0"/>
-              <a:t>11/19/2025</a:t>
+              <a:t>11/22/2025</a:t>
             </a:fld>
             <a:endParaRPr lang="en-US"/>
           </a:p>
@@ -466,7 +466,7 @@
           <a:p>
             <a:fld id="{5C562405-84C2-4048-9C4C-220ACFA9AFD9}" type="datetimeFigureOut">
               <a:rPr lang="en-US" smtClean="0"/>
-              <a:t>11/19/2025</a:t>
+              <a:t>11/22/2025</a:t>
             </a:fld>
             <a:endParaRPr lang="en-US"/>
           </a:p>
@@ -674,7 +674,7 @@
           <a:p>
             <a:fld id="{5C562405-84C2-4048-9C4C-220ACFA9AFD9}" type="datetimeFigureOut">
               <a:rPr lang="en-US" smtClean="0"/>
-              <a:t>11/19/2025</a:t>
+              <a:t>11/22/2025</a:t>
             </a:fld>
             <a:endParaRPr lang="en-US"/>
           </a:p>
@@ -872,7 +872,7 @@
           <a:p>
             <a:fld id="{5C562405-84C2-4048-9C4C-220ACFA9AFD9}" type="datetimeFigureOut">
               <a:rPr lang="en-US" smtClean="0"/>
-              <a:t>11/19/2025</a:t>
+              <a:t>11/22/2025</a:t>
             </a:fld>
             <a:endParaRPr lang="en-US"/>
           </a:p>
@@ -1147,7 +1147,7 @@
           <a:p>
             <a:fld id="{5C562405-84C2-4048-9C4C-220ACFA9AFD9}" type="datetimeFigureOut">
               <a:rPr lang="en-US" smtClean="0"/>
-              <a:t>11/19/2025</a:t>
+              <a:t>11/22/2025</a:t>
             </a:fld>
             <a:endParaRPr lang="en-US"/>
           </a:p>
@@ -1412,7 +1412,7 @@
           <a:p>
             <a:fld id="{5C562405-84C2-4048-9C4C-220ACFA9AFD9}" type="datetimeFigureOut">
               <a:rPr lang="en-US" smtClean="0"/>
-              <a:t>11/19/2025</a:t>
+              <a:t>11/22/2025</a:t>
             </a:fld>
             <a:endParaRPr lang="en-US"/>
           </a:p>
@@ -1824,7 +1824,7 @@
           <a:p>
             <a:fld id="{5C562405-84C2-4048-9C4C-220ACFA9AFD9}" type="datetimeFigureOut">
               <a:rPr lang="en-US" smtClean="0"/>
-              <a:t>11/19/2025</a:t>
+              <a:t>11/22/2025</a:t>
             </a:fld>
             <a:endParaRPr lang="en-US"/>
           </a:p>
@@ -1965,7 +1965,7 @@
           <a:p>
             <a:fld id="{5C562405-84C2-4048-9C4C-220ACFA9AFD9}" type="datetimeFigureOut">
               <a:rPr lang="en-US" smtClean="0"/>
-              <a:t>11/19/2025</a:t>
+              <a:t>11/22/2025</a:t>
             </a:fld>
             <a:endParaRPr lang="en-US"/>
           </a:p>
@@ -2078,7 +2078,7 @@
           <a:p>
             <a:fld id="{5C562405-84C2-4048-9C4C-220ACFA9AFD9}" type="datetimeFigureOut">
               <a:rPr lang="en-US" smtClean="0"/>
-              <a:t>11/19/2025</a:t>
+              <a:t>11/22/2025</a:t>
             </a:fld>
             <a:endParaRPr lang="en-US"/>
           </a:p>
@@ -2389,7 +2389,7 @@
           <a:p>
             <a:fld id="{5C562405-84C2-4048-9C4C-220ACFA9AFD9}" type="datetimeFigureOut">
               <a:rPr lang="en-US" smtClean="0"/>
-              <a:t>11/19/2025</a:t>
+              <a:t>11/22/2025</a:t>
             </a:fld>
             <a:endParaRPr lang="en-US"/>
           </a:p>
@@ -2677,7 +2677,7 @@
           <a:p>
             <a:fld id="{5C562405-84C2-4048-9C4C-220ACFA9AFD9}" type="datetimeFigureOut">
               <a:rPr lang="en-US" smtClean="0"/>
-              <a:t>11/19/2025</a:t>
+              <a:t>11/22/2025</a:t>
             </a:fld>
             <a:endParaRPr lang="en-US"/>
           </a:p>
@@ -2918,7 +2918,7 @@
           <a:p>
             <a:fld id="{5C562405-84C2-4048-9C4C-220ACFA9AFD9}" type="datetimeFigureOut">
               <a:rPr lang="en-US" smtClean="0"/>
-              <a:t>11/19/2025</a:t>
+              <a:t>11/22/2025</a:t>
             </a:fld>
             <a:endParaRPr lang="en-US"/>
           </a:p>
@@ -5671,6 +5671,9 @@
                     <p:cTn id="3" fill="hold">
                       <p:stCondLst>
                         <p:cond delay="indefinite"/>
+                        <p:cond evt="onBegin" delay="0">
+                          <p:tn val="2"/>
+                        </p:cond>
                       </p:stCondLst>
                       <p:childTnLst>
                         <p:par>
@@ -5680,7 +5683,7 @@
                             </p:stCondLst>
                             <p:childTnLst>
                               <p:par>
-                                <p:cTn id="5" presetID="2" presetClass="entr" presetSubtype="8" decel="53333" fill="hold" grpId="0" nodeType="clickEffect">
+                                <p:cTn id="5" presetID="2" presetClass="entr" presetSubtype="8" decel="53333" fill="hold" grpId="0" nodeType="withEffect">
                                   <p:stCondLst>
                                     <p:cond delay="0"/>
                                   </p:stCondLst>
@@ -6317,30 +6320,21 @@
                             </p:childTnLst>
                           </p:cTn>
                         </p:par>
-                      </p:childTnLst>
-                    </p:cTn>
-                  </p:par>
-                  <p:par>
-                    <p:cTn id="42" fill="hold">
-                      <p:stCondLst>
-                        <p:cond delay="indefinite"/>
-                      </p:stCondLst>
-                      <p:childTnLst>
                         <p:par>
-                          <p:cTn id="43" fill="hold">
+                          <p:cTn id="42" fill="hold">
                             <p:stCondLst>
-                              <p:cond delay="0"/>
+                              <p:cond delay="2400"/>
                             </p:stCondLst>
                             <p:childTnLst>
                               <p:par>
-                                <p:cTn id="44" presetID="2" presetClass="entr" presetSubtype="4" decel="53333" fill="hold" grpId="0" nodeType="clickEffect">
+                                <p:cTn id="43" presetID="2" presetClass="entr" presetSubtype="4" decel="53333" fill="hold" grpId="0" nodeType="afterEffect">
                                   <p:stCondLst>
                                     <p:cond delay="0"/>
                                   </p:stCondLst>
                                   <p:childTnLst>
                                     <p:set>
                                       <p:cBhvr>
-                                        <p:cTn id="45" dur="1" fill="hold">
+                                        <p:cTn id="44" dur="1" fill="hold">
                                           <p:stCondLst>
                                             <p:cond delay="0"/>
                                           </p:stCondLst>
@@ -6358,7 +6352,7 @@
                                     </p:set>
                                     <p:anim calcmode="lin" valueType="num">
                                       <p:cBhvr additive="base">
-                                        <p:cTn id="46" dur="750" fill="hold"/>
+                                        <p:cTn id="45" dur="750" fill="hold"/>
                                         <p:tgtEl>
                                           <p:spTgt spid="89"/>
                                         </p:tgtEl>
@@ -6381,7 +6375,7 @@
                                     </p:anim>
                                     <p:anim calcmode="lin" valueType="num">
                                       <p:cBhvr additive="base">
-                                        <p:cTn id="47" dur="750" fill="hold"/>
+                                        <p:cTn id="46" dur="750" fill="hold"/>
                                         <p:tgtEl>
                                           <p:spTgt spid="89"/>
                                         </p:tgtEl>
@@ -6406,14 +6400,14 @@
                                 </p:cTn>
                               </p:par>
                               <p:par>
-                                <p:cTn id="48" presetID="10" presetClass="entr" presetSubtype="0" fill="hold" grpId="0" nodeType="withEffect">
+                                <p:cTn id="47" presetID="10" presetClass="entr" presetSubtype="0" fill="hold" grpId="0" nodeType="withEffect">
                                   <p:stCondLst>
                                     <p:cond delay="500"/>
                                   </p:stCondLst>
                                   <p:childTnLst>
                                     <p:set>
                                       <p:cBhvr>
-                                        <p:cTn id="49" dur="1" fill="hold">
+                                        <p:cTn id="48" dur="1" fill="hold">
                                           <p:stCondLst>
                                             <p:cond delay="0"/>
                                           </p:stCondLst>
@@ -6431,7 +6425,7 @@
                                     </p:set>
                                     <p:animEffect transition="in" filter="fade">
                                       <p:cBhvr>
-                                        <p:cTn id="50" dur="500"/>
+                                        <p:cTn id="49" dur="500"/>
                                         <p:tgtEl>
                                           <p:spTgt spid="25"/>
                                         </p:tgtEl>
@@ -6441,14 +6435,14 @@
                                 </p:cTn>
                               </p:par>
                               <p:par>
-                                <p:cTn id="51" presetID="2" presetClass="entr" presetSubtype="4" decel="53333" fill="hold" grpId="0" nodeType="withEffect">
+                                <p:cTn id="50" presetID="2" presetClass="entr" presetSubtype="4" decel="53333" fill="hold" grpId="0" nodeType="withEffect">
                                   <p:stCondLst>
                                     <p:cond delay="500"/>
                                   </p:stCondLst>
                                   <p:childTnLst>
                                     <p:set>
                                       <p:cBhvr>
-                                        <p:cTn id="52" dur="1" fill="hold">
+                                        <p:cTn id="51" dur="1" fill="hold">
                                           <p:stCondLst>
                                             <p:cond delay="0"/>
                                           </p:stCondLst>
@@ -6466,7 +6460,7 @@
                                     </p:set>
                                     <p:anim calcmode="lin" valueType="num">
                                       <p:cBhvr additive="base">
-                                        <p:cTn id="53" dur="750" fill="hold"/>
+                                        <p:cTn id="52" dur="750" fill="hold"/>
                                         <p:tgtEl>
                                           <p:spTgt spid="28"/>
                                         </p:tgtEl>
@@ -6489,7 +6483,7 @@
                                     </p:anim>
                                     <p:anim calcmode="lin" valueType="num">
                                       <p:cBhvr additive="base">
-                                        <p:cTn id="54" dur="750" fill="hold"/>
+                                        <p:cTn id="53" dur="750" fill="hold"/>
                                         <p:tgtEl>
                                           <p:spTgt spid="28"/>
                                         </p:tgtEl>
@@ -6514,14 +6508,14 @@
                                 </p:cTn>
                               </p:par>
                               <p:par>
-                                <p:cTn id="55" presetID="2" presetClass="entr" presetSubtype="4" decel="53333" fill="hold" grpId="0" nodeType="withEffect">
+                                <p:cTn id="54" presetID="2" presetClass="entr" presetSubtype="4" decel="53333" fill="hold" grpId="0" nodeType="withEffect">
                                   <p:stCondLst>
                                     <p:cond delay="650"/>
                                   </p:stCondLst>
                                   <p:childTnLst>
                                     <p:set>
                                       <p:cBhvr>
-                                        <p:cTn id="56" dur="1" fill="hold">
+                                        <p:cTn id="55" dur="1" fill="hold">
                                           <p:stCondLst>
                                             <p:cond delay="0"/>
                                           </p:stCondLst>
@@ -6539,7 +6533,7 @@
                                     </p:set>
                                     <p:anim calcmode="lin" valueType="num">
                                       <p:cBhvr additive="base">
-                                        <p:cTn id="57" dur="750" fill="hold"/>
+                                        <p:cTn id="56" dur="750" fill="hold"/>
                                         <p:tgtEl>
                                           <p:spTgt spid="27"/>
                                         </p:tgtEl>
@@ -6562,7 +6556,7 @@
                                     </p:anim>
                                     <p:anim calcmode="lin" valueType="num">
                                       <p:cBhvr additive="base">
-                                        <p:cTn id="58" dur="750" fill="hold"/>
+                                        <p:cTn id="57" dur="750" fill="hold"/>
                                         <p:tgtEl>
                                           <p:spTgt spid="27"/>
                                         </p:tgtEl>
@@ -6589,30 +6583,21 @@
                             </p:childTnLst>
                           </p:cTn>
                         </p:par>
-                      </p:childTnLst>
-                    </p:cTn>
-                  </p:par>
-                  <p:par>
-                    <p:cTn id="59" fill="hold">
-                      <p:stCondLst>
-                        <p:cond delay="indefinite"/>
-                      </p:stCondLst>
-                      <p:childTnLst>
                         <p:par>
-                          <p:cTn id="60" fill="hold">
+                          <p:cTn id="58" fill="hold">
                             <p:stCondLst>
-                              <p:cond delay="0"/>
+                              <p:cond delay="3800"/>
                             </p:stCondLst>
                             <p:childTnLst>
                               <p:par>
-                                <p:cTn id="61" presetID="2" presetClass="entr" presetSubtype="4" decel="53333" fill="hold" grpId="0" nodeType="clickEffect">
+                                <p:cTn id="59" presetID="2" presetClass="entr" presetSubtype="4" decel="53333" fill="hold" grpId="0" nodeType="afterEffect">
                                   <p:stCondLst>
                                     <p:cond delay="0"/>
                                   </p:stCondLst>
                                   <p:childTnLst>
                                     <p:set>
                                       <p:cBhvr>
-                                        <p:cTn id="62" dur="1" fill="hold">
+                                        <p:cTn id="60" dur="1" fill="hold">
                                           <p:stCondLst>
                                             <p:cond delay="0"/>
                                           </p:stCondLst>
@@ -6630,7 +6615,7 @@
                                     </p:set>
                                     <p:anim calcmode="lin" valueType="num">
                                       <p:cBhvr additive="base">
-                                        <p:cTn id="63" dur="750" fill="hold"/>
+                                        <p:cTn id="61" dur="750" fill="hold"/>
                                         <p:tgtEl>
                                           <p:spTgt spid="81"/>
                                         </p:tgtEl>
@@ -6653,7 +6638,7 @@
                                     </p:anim>
                                     <p:anim calcmode="lin" valueType="num">
                                       <p:cBhvr additive="base">
-                                        <p:cTn id="64" dur="750" fill="hold"/>
+                                        <p:cTn id="62" dur="750" fill="hold"/>
                                         <p:tgtEl>
                                           <p:spTgt spid="81"/>
                                         </p:tgtEl>
@@ -6678,14 +6663,14 @@
                                 </p:cTn>
                               </p:par>
                               <p:par>
-                                <p:cTn id="65" presetID="10" presetClass="entr" presetSubtype="0" fill="hold" grpId="0" nodeType="withEffect">
+                                <p:cTn id="63" presetID="10" presetClass="entr" presetSubtype="0" fill="hold" grpId="0" nodeType="withEffect">
                                   <p:stCondLst>
                                     <p:cond delay="500"/>
                                   </p:stCondLst>
                                   <p:childTnLst>
                                     <p:set>
                                       <p:cBhvr>
-                                        <p:cTn id="66" dur="1" fill="hold">
+                                        <p:cTn id="64" dur="1" fill="hold">
                                           <p:stCondLst>
                                             <p:cond delay="0"/>
                                           </p:stCondLst>
@@ -6703,7 +6688,7 @@
                                     </p:set>
                                     <p:animEffect transition="in" filter="fade">
                                       <p:cBhvr>
-                                        <p:cTn id="67" dur="500"/>
+                                        <p:cTn id="65" dur="500"/>
                                         <p:tgtEl>
                                           <p:spTgt spid="36"/>
                                         </p:tgtEl>
@@ -6713,14 +6698,14 @@
                                 </p:cTn>
                               </p:par>
                               <p:par>
-                                <p:cTn id="68" presetID="2" presetClass="entr" presetSubtype="4" decel="53333" fill="hold" grpId="0" nodeType="withEffect">
+                                <p:cTn id="66" presetID="2" presetClass="entr" presetSubtype="4" decel="53333" fill="hold" grpId="0" nodeType="withEffect">
                                   <p:stCondLst>
                                     <p:cond delay="500"/>
                                   </p:stCondLst>
                                   <p:childTnLst>
                                     <p:set>
                                       <p:cBhvr>
-                                        <p:cTn id="69" dur="1" fill="hold">
+                                        <p:cTn id="67" dur="1" fill="hold">
                                           <p:stCondLst>
                                             <p:cond delay="0"/>
                                           </p:stCondLst>
@@ -6738,7 +6723,7 @@
                                     </p:set>
                                     <p:anim calcmode="lin" valueType="num">
                                       <p:cBhvr additive="base">
-                                        <p:cTn id="70" dur="750" fill="hold"/>
+                                        <p:cTn id="68" dur="750" fill="hold"/>
                                         <p:tgtEl>
                                           <p:spTgt spid="40"/>
                                         </p:tgtEl>
@@ -6761,7 +6746,7 @@
                                     </p:anim>
                                     <p:anim calcmode="lin" valueType="num">
                                       <p:cBhvr additive="base">
-                                        <p:cTn id="71" dur="750" fill="hold"/>
+                                        <p:cTn id="69" dur="750" fill="hold"/>
                                         <p:tgtEl>
                                           <p:spTgt spid="40"/>
                                         </p:tgtEl>
@@ -6786,14 +6771,14 @@
                                 </p:cTn>
                               </p:par>
                               <p:par>
-                                <p:cTn id="72" presetID="2" presetClass="entr" presetSubtype="4" decel="53333" fill="hold" grpId="0" nodeType="withEffect">
+                                <p:cTn id="70" presetID="2" presetClass="entr" presetSubtype="4" decel="53333" fill="hold" grpId="0" nodeType="withEffect">
                                   <p:stCondLst>
                                     <p:cond delay="650"/>
                                   </p:stCondLst>
                                   <p:childTnLst>
                                     <p:set>
                                       <p:cBhvr>
-                                        <p:cTn id="73" dur="1" fill="hold">
+                                        <p:cTn id="71" dur="1" fill="hold">
                                           <p:stCondLst>
                                             <p:cond delay="0"/>
                                           </p:stCondLst>
@@ -6811,7 +6796,7 @@
                                     </p:set>
                                     <p:anim calcmode="lin" valueType="num">
                                       <p:cBhvr additive="base">
-                                        <p:cTn id="74" dur="750" fill="hold"/>
+                                        <p:cTn id="72" dur="750" fill="hold"/>
                                         <p:tgtEl>
                                           <p:spTgt spid="39"/>
                                         </p:tgtEl>
@@ -6834,7 +6819,7 @@
                                     </p:anim>
                                     <p:anim calcmode="lin" valueType="num">
                                       <p:cBhvr additive="base">
-                                        <p:cTn id="75" dur="750" fill="hold"/>
+                                        <p:cTn id="73" dur="750" fill="hold"/>
                                         <p:tgtEl>
                                           <p:spTgt spid="39"/>
                                         </p:tgtEl>
@@ -6861,30 +6846,21 @@
                             </p:childTnLst>
                           </p:cTn>
                         </p:par>
-                      </p:childTnLst>
-                    </p:cTn>
-                  </p:par>
-                  <p:par>
-                    <p:cTn id="76" fill="hold">
-                      <p:stCondLst>
-                        <p:cond delay="indefinite"/>
-                      </p:stCondLst>
-                      <p:childTnLst>
                         <p:par>
-                          <p:cTn id="77" fill="hold">
+                          <p:cTn id="74" fill="hold">
                             <p:stCondLst>
-                              <p:cond delay="0"/>
+                              <p:cond delay="5200"/>
                             </p:stCondLst>
                             <p:childTnLst>
                               <p:par>
-                                <p:cTn id="78" presetID="2" presetClass="entr" presetSubtype="4" decel="53333" fill="hold" grpId="0" nodeType="clickEffect">
+                                <p:cTn id="75" presetID="2" presetClass="entr" presetSubtype="4" decel="53333" fill="hold" grpId="0" nodeType="afterEffect">
                                   <p:stCondLst>
                                     <p:cond delay="0"/>
                                   </p:stCondLst>
                                   <p:childTnLst>
                                     <p:set>
                                       <p:cBhvr>
-                                        <p:cTn id="79" dur="1" fill="hold">
+                                        <p:cTn id="76" dur="1" fill="hold">
                                           <p:stCondLst>
                                             <p:cond delay="0"/>
                                           </p:stCondLst>
@@ -6902,7 +6878,7 @@
                                     </p:set>
                                     <p:anim calcmode="lin" valueType="num">
                                       <p:cBhvr additive="base">
-                                        <p:cTn id="80" dur="750" fill="hold"/>
+                                        <p:cTn id="77" dur="750" fill="hold"/>
                                         <p:tgtEl>
                                           <p:spTgt spid="85"/>
                                         </p:tgtEl>
@@ -6925,7 +6901,7 @@
                                     </p:anim>
                                     <p:anim calcmode="lin" valueType="num">
                                       <p:cBhvr additive="base">
-                                        <p:cTn id="81" dur="750" fill="hold"/>
+                                        <p:cTn id="78" dur="750" fill="hold"/>
                                         <p:tgtEl>
                                           <p:spTgt spid="85"/>
                                         </p:tgtEl>
@@ -6950,14 +6926,14 @@
                                 </p:cTn>
                               </p:par>
                               <p:par>
-                                <p:cTn id="82" presetID="10" presetClass="entr" presetSubtype="0" fill="hold" grpId="0" nodeType="withEffect">
+                                <p:cTn id="79" presetID="10" presetClass="entr" presetSubtype="0" fill="hold" grpId="0" nodeType="withEffect">
                                   <p:stCondLst>
                                     <p:cond delay="500"/>
                                   </p:stCondLst>
                                   <p:childTnLst>
                                     <p:set>
                                       <p:cBhvr>
-                                        <p:cTn id="83" dur="1" fill="hold">
+                                        <p:cTn id="80" dur="1" fill="hold">
                                           <p:stCondLst>
                                             <p:cond delay="0"/>
                                           </p:stCondLst>
@@ -6975,7 +6951,7 @@
                                     </p:set>
                                     <p:animEffect transition="in" filter="fade">
                                       <p:cBhvr>
-                                        <p:cTn id="84" dur="500"/>
+                                        <p:cTn id="81" dur="500"/>
                                         <p:tgtEl>
                                           <p:spTgt spid="37"/>
                                         </p:tgtEl>
@@ -6985,14 +6961,14 @@
                                 </p:cTn>
                               </p:par>
                               <p:par>
-                                <p:cTn id="85" presetID="2" presetClass="entr" presetSubtype="4" decel="53333" fill="hold" grpId="0" nodeType="withEffect">
+                                <p:cTn id="82" presetID="2" presetClass="entr" presetSubtype="4" decel="53333" fill="hold" grpId="0" nodeType="withEffect">
                                   <p:stCondLst>
                                     <p:cond delay="500"/>
                                   </p:stCondLst>
                                   <p:childTnLst>
                                     <p:set>
                                       <p:cBhvr>
-                                        <p:cTn id="86" dur="1" fill="hold">
+                                        <p:cTn id="83" dur="1" fill="hold">
                                           <p:stCondLst>
                                             <p:cond delay="0"/>
                                           </p:stCondLst>
@@ -7010,7 +6986,7 @@
                                     </p:set>
                                     <p:anim calcmode="lin" valueType="num">
                                       <p:cBhvr additive="base">
-                                        <p:cTn id="87" dur="750" fill="hold"/>
+                                        <p:cTn id="84" dur="750" fill="hold"/>
                                         <p:tgtEl>
                                           <p:spTgt spid="43"/>
                                         </p:tgtEl>
@@ -7033,7 +7009,7 @@
                                     </p:anim>
                                     <p:anim calcmode="lin" valueType="num">
                                       <p:cBhvr additive="base">
-                                        <p:cTn id="88" dur="750" fill="hold"/>
+                                        <p:cTn id="85" dur="750" fill="hold"/>
                                         <p:tgtEl>
                                           <p:spTgt spid="43"/>
                                         </p:tgtEl>
@@ -7058,14 +7034,14 @@
                                 </p:cTn>
                               </p:par>
                               <p:par>
-                                <p:cTn id="89" presetID="2" presetClass="entr" presetSubtype="4" decel="53333" fill="hold" grpId="0" nodeType="withEffect">
+                                <p:cTn id="86" presetID="2" presetClass="entr" presetSubtype="4" decel="53333" fill="hold" grpId="0" nodeType="withEffect">
                                   <p:stCondLst>
                                     <p:cond delay="650"/>
                                   </p:stCondLst>
                                   <p:childTnLst>
                                     <p:set>
                                       <p:cBhvr>
-                                        <p:cTn id="90" dur="1" fill="hold">
+                                        <p:cTn id="87" dur="1" fill="hold">
                                           <p:stCondLst>
                                             <p:cond delay="0"/>
                                           </p:stCondLst>
@@ -7083,7 +7059,7 @@
                                     </p:set>
                                     <p:anim calcmode="lin" valueType="num">
                                       <p:cBhvr additive="base">
-                                        <p:cTn id="91" dur="750" fill="hold"/>
+                                        <p:cTn id="88" dur="750" fill="hold"/>
                                         <p:tgtEl>
                                           <p:spTgt spid="42"/>
                                         </p:tgtEl>
@@ -7106,7 +7082,7 @@
                                     </p:anim>
                                     <p:anim calcmode="lin" valueType="num">
                                       <p:cBhvr additive="base">
-                                        <p:cTn id="92" dur="750" fill="hold"/>
+                                        <p:cTn id="89" dur="750" fill="hold"/>
                                         <p:tgtEl>
                                           <p:spTgt spid="42"/>
                                         </p:tgtEl>

</xml_diff>